<commit_message>
seminar 11장 + 그림: 'past 25 %' 와 범례 문구 교체
'moved past 25 %' 는 문턱을 위치처럼 말한다 (1저자: '이게 뭔뜻이야')
  -> 'changed by more than 25 %'
범례 'distorted too far — dropped here' 는 대시 + 'here' 가 뭘 가리키는지 불명
  -> 'dropped (> 25 %)'  · 산점도는 'dropped, > 25 % (100)'
     문턱이 범례에 있으니 점선이 뭔지도 같이 설명된다.
소불릿2 에서 'an energy cut would have kept all 100' 을 뺐다 -
  'of the same size' 단서 없이 쓰면 실측보다 세다. 근거는 밑줄이 진다.

Co-Authored-By: Claude Opus 5 <noreply@anthropic.com>
Claude-Session: https://claude.ai/code/session_01L44TWYrHkcm4PH5ihWSSCw
</commit_message>
<xml_diff>
--- a/docs/Slide11_lowcost_relaxation.pptx
+++ b/docs/Slide11_lowcost_relaxation.pptx
@@ -1706,7 +1706,7 @@
                 <a:ea typeface="Arial"/>
                 <a:cs typeface="Arial"/>
               </a:rPr>
-              <a:t>; an energy cut would have kept all 100.</a:t>
+              <a:t>.</a:t>
             </a:r>
           </a:p>
         </p:txBody>
@@ -1887,14 +1887,14 @@
       </p:sp>
       <p:pic xmlns:a="http://schemas.openxmlformats.org/drawingml/2006/main" xmlns:r="http://schemas.openxmlformats.org/officeDocument/2006/relationships">
         <p:nvPicPr>
-          <p:cNvPr id="39" name="Picture 38" descr="image.png"/>
+          <p:cNvPr id="39" name="Picture 38" descr="step3_survival.png"/>
           <p:cNvPicPr>
             <a:picLocks noChangeAspect="1"/>
           </p:cNvPicPr>
           <p:nvPr/>
         </p:nvPicPr>
         <p:blipFill>
-          <a:blip r:embed="rId3"/>
+          <a:blip r:embed="rId4"/>
           <a:stretch>
             <a:fillRect/>
           </a:stretch>
@@ -1918,7 +1918,7 @@
           <p:nvPr/>
         </p:nvPicPr>
         <p:blipFill>
-          <a:blip r:embed="rId4"/>
+          <a:blip r:embed="rId5"/>
           <a:stretch>
             <a:fillRect/>
           </a:stretch>
@@ -1998,7 +1998,7 @@
                 </a:solidFill>
                 <a:latin typeface="Arial"/>
               </a:rPr>
-              <a:t>100 of 3,615 moved past 25 %</a:t>
+              <a:t>100 of 3,615 changed by more than 25 %</a:t>
             </a:r>
             <a:r>
               <a:rPr sz="1150" b="0">
@@ -2007,7 +2007,7 @@
                 </a:solidFill>
                 <a:latin typeface="Arial"/>
               </a:rPr>
-              <a:t>; an energy cut of the same size overlaps with none of them.</a:t>
+              <a:t>; by energy they look ordinary.</a:t>
             </a:r>
           </a:p>
         </p:txBody>

</xml_diff>